<commit_message>
fix(tv3): cap nhat speaker notes slide 7-9, hoan thien bao cao word va dong bo provenance PR #43
</commit_message>
<xml_diff>
--- a/Bo_nop_TV3_TranTienDat/Minh_chung/TV3_Slides_7-9.pptx
+++ b/Bo_nop_TV3_TranTienDat/Minh_chung/TV3_Slides_7-9.pptx
@@ -504,44 +504,105 @@
           <a:lstStyle/>
           <a:p>
             <a:r>
-              <a:rPr lang="vi-VN"/>
-              <a:t>SLIDE 10 · khoảng 40 giây</a:t>
-            </a:r>
-            <a:endParaRPr lang="vi-VN"/>
-          </a:p>
-          <a:p>
-            <a:endParaRPr lang="vi-VN"/>
-          </a:p>
-          <a:p>
-            <a:r>
-              <a:rPr lang="vi-VN"/>
-              <a:t>Em là Nguyễn Quang Vinh, phụ trách tính lương. Đầu vào gồm mức lương của kỳ, ngày công, phụ cấp và khấu trừ. Tiền công bằng lương cơ bản chia công chuẩn, nhân công thực tế; thực nhận cộng phụ cấp rồi trừ khấu trừ. Ví dụ GUI tháng 10/2026: A nhận 730.000đ, B nhận 0đ.</a:t>
-            </a:r>
-            <a:endParaRPr lang="vi-VN"/>
-          </a:p>
-          <a:p>
-            <a:endParaRPr lang="vi-VN"/>
-          </a:p>
-          <a:p>
-            <a:r>
-              <a:rPr lang="vi-VN"/>
-              <a:t>Minh chứng: Minh_chung/TV4_GUI_Live.log; TV4_GUI_TinhLuong_102026.png. GUI desktop Robot 11/10/2026 04:03:38 +07; 31 assertions PASS; Payroll_Officer; QA riêng đã dọn.</a:t>
-            </a:r>
-            <a:endParaRPr lang="vi-VN"/>
-          </a:p>
-          <a:p>
-            <a:r>
-              <a:rPr lang="vi-VN"/>
-              <a:t>GUI đã kiểm tự động; chưa rehearsal lời nói và thao tác tay.</a:t>
-            </a:r>
-            <a:endParaRPr lang="vi-VN"/>
-          </a:p>
-          <a:p>
-            <a:r>
-              <a:rPr lang="vi-VN"/>
-              <a:t>Thông tin lần chạy: Minh_chung/THONG_TIN_MINH_CHUNG.txt.</a:t>
-            </a:r>
-            <a:endParaRPr lang="vi-VN"/>
+              <a:rPr lang="en-US" altLang="en-US"/>
+              <a:t>Slide 7 — Dữ liệu phụ cấp và khấu trừ</a:t>
+            </a:r>
+            <a:endParaRPr lang="en-US" altLang="en-US"/>
+          </a:p>
+          <a:p>
+            <a:r>
+              <a:rPr lang="" altLang="en-US"/>
+              <a:t>Ý </a:t>
+            </a:r>
+            <a:r>
+              <a:rPr lang="en-US" altLang="en-US"/>
+              <a:t>chính trên slide: Hai bảng theo nhân viên và kỳ; khóa ngoại; CHECK tiền/tháng/n</a:t>
+            </a:r>
+            <a:r>
+              <a:rPr lang="" altLang="en-US"/>
+              <a:t>ă</a:t>
+            </a:r>
+            <a:r>
+              <a:rPr lang="en-US" altLang="en-US"/>
+              <a:t>m; không có quy tắc UNIQUE theo tên khoản.</a:t>
+            </a:r>
+            <a:endParaRPr lang="en-US" altLang="en-US"/>
+          </a:p>
+          <a:p>
+            <a:endParaRPr lang="en-US" altLang="en-US"/>
+          </a:p>
+          <a:p>
+            <a:r>
+              <a:rPr lang="en-US" altLang="en-US"/>
+              <a:t>Lời nói (40 giây):</a:t>
+            </a:r>
+            <a:endParaRPr lang="en-US" altLang="en-US"/>
+          </a:p>
+          <a:p>
+            <a:endParaRPr lang="en-US" altLang="en-US"/>
+          </a:p>
+          <a:p>
+            <a:r>
+              <a:rPr lang="en-US" altLang="en-US"/>
+              <a:t>“Phần của em là phụ cấp và khấu trừ theo từng nhân viên trong từng kỳ l</a:t>
+            </a:r>
+            <a:r>
+              <a:rPr lang="" altLang="en-US"/>
+              <a:t>ư</a:t>
+            </a:r>
+            <a:r>
+              <a:rPr lang="en-US" altLang="en-US"/>
+              <a:t>ơng. Hai bảng l</a:t>
+            </a:r>
+            <a:r>
+              <a:rPr lang="" altLang="en-US"/>
+              <a:t>ư</a:t>
+            </a:r>
+            <a:r>
+              <a:rPr lang="en-US" altLang="en-US"/>
+              <a:t>u khoản phát sinh riêng, liên kết nhân viên bằng khóa ngoại nên không tạo dữ liệu mồ côi. CHECK chặn số tiền âm, tháng ngoài 1 </a:t>
+            </a:r>
+            <a:r>
+              <a:rPr lang="" altLang="en-US"/>
+              <a:t>đ</a:t>
+            </a:r>
+            <a:r>
+              <a:rPr lang="en-US" altLang="en-US"/>
+              <a:t>ến 12 và n</a:t>
+            </a:r>
+            <a:r>
+              <a:rPr lang="" altLang="en-US"/>
+              <a:t>ă</a:t>
+            </a:r>
+            <a:r>
+              <a:rPr lang="en-US" altLang="en-US"/>
+              <a:t>m tr</a:t>
+            </a:r>
+            <a:r>
+              <a:rPr lang="" altLang="en-US"/>
+              <a:t>ư</a:t>
+            </a:r>
+            <a:r>
+              <a:rPr lang="en-US" altLang="en-US"/>
+              <a:t>ớc 2020. Một nhân viên có thể có nhiều khoản cùng kỳ; tên khoản không phải khóa duy nhất. Dữ liệu này là </a:t>
+            </a:r>
+            <a:r>
+              <a:rPr lang="" altLang="en-US"/>
+              <a:t>đ</a:t>
+            </a:r>
+            <a:r>
+              <a:rPr lang="en-US" altLang="en-US"/>
+              <a:t>ầu vào </a:t>
+            </a:r>
+            <a:r>
+              <a:rPr lang="" altLang="en-US"/>
+              <a:t>đ</a:t>
+            </a:r>
+            <a:r>
+              <a:rPr lang="en-US" altLang="en-US"/>
+              <a:t>ể tính thực nhận: tiền công cộng tổng phụ cấp rồi trừ tổng khấu trừ.”</a:t>
+            </a:r>
+            <a:endParaRPr lang="en-US" altLang="en-US"/>
           </a:p>
         </p:txBody>
       </p:sp>
@@ -620,37 +681,105 @@
           <a:lstStyle/>
           <a:p>
             <a:r>
-              <a:rPr lang="vi-VN"/>
-              <a:t>SLIDE 11 · khoảng 45 giây</a:t>
-            </a:r>
-            <a:endParaRPr lang="vi-VN"/>
-          </a:p>
-          <a:p>
-            <a:endParaRPr lang="vi-VN"/>
-          </a:p>
-          <a:p>
-            <a:r>
-              <a:rPr lang="vi-VN"/>
-              <a:t>Procedure kiểm tra đầu vào, khóa kỳ và nguồn, rồi ghi bảng lương và chi tiết trong transaction. Kỳ chưa chốt tính lại trên cùng mã kỳ. Nếu ghi chi tiết lỗi, TRY CATCH rollback để giữ kết quả trước. Kỳ đã chốt không cho tính lại. Mức lương kỳ cũ ưu tiên snapshot, tiếp đến lịch sử hiệu lực, cuối cùng lương hiện tại; lịch sử đã mất không tự khôi phục.</a:t>
-            </a:r>
-            <a:endParaRPr lang="vi-VN"/>
-          </a:p>
-          <a:p>
-            <a:endParaRPr lang="vi-VN"/>
-          </a:p>
-          <a:p>
-            <a:r>
-              <a:rPr lang="vi-VN"/>
-              <a:t>SSMS E2E 10/10 PASS, 10/10/2026 20:53:42–44 +07, SPID 56, mã kỳ 8; gồm tính lại/rollback. Minh_chung/TV4_Payroll_E2E.log; TV4_E2E_10Steps_Pass.png.</a:t>
-            </a:r>
-            <a:endParaRPr lang="vi-VN"/>
-          </a:p>
-          <a:p>
-            <a:r>
-              <a:rPr lang="vi-VN"/>
-              <a:t>Thông tin lần chạy: Minh_chung/THONG_TIN_MINH_CHUNG.txt.</a:t>
-            </a:r>
-            <a:endParaRPr lang="vi-VN"/>
+              <a:rPr lang="en-US" altLang="en-US"/>
+              <a:t>Slide 8 — Tổng hợp và bảo vệ kỳ l</a:t>
+            </a:r>
+            <a:r>
+              <a:rPr lang="" altLang="en-US"/>
+              <a:t>ư</a:t>
+            </a:r>
+            <a:r>
+              <a:rPr lang="en-US" altLang="en-US"/>
+              <a:t>ơng</a:t>
+            </a:r>
+            <a:endParaRPr lang="en-US" altLang="en-US"/>
+          </a:p>
+          <a:p>
+            <a:r>
+              <a:rPr lang="" altLang="en-US"/>
+              <a:t>Ý </a:t>
+            </a:r>
+            <a:r>
+              <a:rPr lang="en-US" altLang="en-US"/>
+              <a:t>chính trên slide: Function/View tổng hợp; trigger chặn kỳ </a:t>
+            </a:r>
+            <a:r>
+              <a:rPr lang="" altLang="en-US"/>
+              <a:t>đ</a:t>
+            </a:r>
+            <a:r>
+              <a:rPr lang="en-US" altLang="en-US"/>
+              <a:t>ã chốt; procedure xóa kỳ nháp trong transaction; index phục vụ lọc.</a:t>
+            </a:r>
+            <a:endParaRPr lang="en-US" altLang="en-US"/>
+          </a:p>
+          <a:p>
+            <a:endParaRPr lang="en-US" altLang="en-US"/>
+          </a:p>
+          <a:p>
+            <a:r>
+              <a:rPr lang="en-US" altLang="en-US"/>
+              <a:t>Lời nói (45 giây):</a:t>
+            </a:r>
+            <a:endParaRPr lang="en-US" altLang="en-US"/>
+          </a:p>
+          <a:p>
+            <a:endParaRPr lang="en-US" altLang="en-US"/>
+          </a:p>
+          <a:p>
+            <a:r>
+              <a:rPr lang="en-US" altLang="en-US"/>
+              <a:t>“fn_TongKhauTru trả tổng khấu trừ của một nhân viên trong một tháng, còn vw_TongPhuCapThang gom số khoản và tổng tiền </a:t>
+            </a:r>
+            <a:r>
+              <a:rPr lang="" altLang="en-US"/>
+              <a:t>đ</a:t>
+            </a:r>
+            <a:r>
+              <a:rPr lang="en-US" altLang="en-US"/>
+              <a:t>ể tra cứu. Khi kỳ </a:t>
+            </a:r>
+            <a:r>
+              <a:rPr lang="" altLang="en-US"/>
+              <a:t>đ</a:t>
+            </a:r>
+            <a:r>
+              <a:rPr lang="en-US" altLang="en-US"/>
+              <a:t>ã chốt, trigger ở module bảo mật khóa dòng kỳ cha bằng UPDLOCK, HOLDLOCK và kiểm tra cả dữ liệu c</a:t>
+            </a:r>
+            <a:r>
+              <a:rPr lang="" altLang="en-US"/>
+              <a:t>ũ </a:t>
+            </a:r>
+            <a:r>
+              <a:rPr lang="en-US" altLang="en-US"/>
+              <a:t>lẫn mới, nên sửa, xóa hoặc chuyển khoản sang kỳ chốt </a:t>
+            </a:r>
+            <a:r>
+              <a:rPr lang="" altLang="en-US"/>
+              <a:t>đ</a:t>
+            </a:r>
+            <a:r>
+              <a:rPr lang="en-US" altLang="en-US"/>
+              <a:t>ều bị từ chối. Khi xóa kỳ nháp, sp_XoaKyLuongChuaChot mở transaction, khóa kỳ, xóa chi tiết tr</a:t>
+            </a:r>
+            <a:r>
+              <a:rPr lang="" altLang="en-US"/>
+              <a:t>ư</a:t>
+            </a:r>
+            <a:r>
+              <a:rPr lang="en-US" altLang="en-US"/>
+              <a:t>ớc bảng l</a:t>
+            </a:r>
+            <a:r>
+              <a:rPr lang="" altLang="en-US"/>
+              <a:t>ư</a:t>
+            </a:r>
+            <a:r>
+              <a:rPr lang="en-US" altLang="en-US"/>
+              <a:t>ơng và rollback nếu có lỗi. Index phụ cấp hỗ trợ lọc theo nhân viên và kỳ.”</a:t>
+            </a:r>
+            <a:endParaRPr lang="en-US" altLang="en-US"/>
           </a:p>
         </p:txBody>
       </p:sp>
@@ -729,58 +858,121 @@
           <a:lstStyle/>
           <a:p>
             <a:r>
-              <a:rPr lang="vi-VN"/>
-              <a:t>SLIDE 12 · khoảng 35 giây</a:t>
-            </a:r>
-            <a:endParaRPr lang="vi-VN"/>
-          </a:p>
-          <a:p>
-            <a:endParaRPr lang="vi-VN"/>
-          </a:p>
-          <a:p>
-            <a:r>
-              <a:rPr lang="vi-VN"/>
-              <a:t>Luồng gọi là Panel → Service kiểm quyền → DAO dùng CallableStatement → procedure trả MaBangLuong OUTPUT. E2E đạt 10/10. Benchmark khấu trừ 30.000 dòng: scan 547 reads, seek 4; cùng 128 dòng và tổng 133.356. Phép đo có hint FORCESCAN/FORCESEEK trên fixture QA, không suy ra tốc độ toàn ứng dụng. Hai session cùng kỳ: B chờ 21.072 ms, cùng mã kỳ và không trùng chi tiết. Mời Đức Anh tiếp tục phần chốt kỳ và quyền truy cập.</a:t>
-            </a:r>
-            <a:endParaRPr lang="vi-VN"/>
-          </a:p>
-          <a:p>
-            <a:endParaRPr lang="vi-VN"/>
-          </a:p>
-          <a:p>
-            <a:r>
-              <a:rPr lang="vi-VN"/>
-              <a:t>Log E2E: Minh_chung/TV4_Payroll_E2E.log.</a:t>
-            </a:r>
-            <a:endParaRPr lang="vi-VN"/>
-          </a:p>
-          <a:p>
-            <a:r>
-              <a:rPr lang="vi-VN"/>
-              <a:t>Log benchmark: Minh_chung/TV4_Payroll_Benchmark.log.</a:t>
-            </a:r>
-            <a:endParaRPr lang="vi-VN"/>
-          </a:p>
-          <a:p>
-            <a:r>
-              <a:rPr lang="vi-VN"/>
-              <a:t>Hai session: Minh_chung/Concurrency_A.log; Minh_chung/Concurrency_B.log.</a:t>
-            </a:r>
-            <a:endParaRPr lang="vi-VN"/>
-          </a:p>
-          <a:p>
-            <a:r>
-              <a:rPr lang="vi-VN"/>
-              <a:t>Actual plans: Minh_chung/TV4_Payroll_Benchmark_FORCED_CLUSTERED_SCAN.sqlplan; Minh_chung/TV4_Payroll_Benchmark_FORCED_COVERING_SEEK.sqlplan.</a:t>
-            </a:r>
-            <a:endParaRPr lang="vi-VN"/>
-          </a:p>
-          <a:p>
-            <a:r>
-              <a:rPr lang="vi-VN"/>
-              <a:t>Nguồn: Minh_chung/THONG_TIN_MINH_CHUNG.txt. Benchmark SSMS SPID 68, 10/10/2026 20:55:42–46; Messages/Results/hai actual plan cùng batch. Native plan chụp 11/10 04:02:44. Concurrency collector A/B 72/73: 21.072 ms; ảnh 11/10 04:03:15 là log mở SSMS, không live hai session lúc chụp.</a:t>
-            </a:r>
-            <a:endParaRPr lang="vi-VN"/>
+              <a:rPr lang="en-US" altLang="en-US"/>
+              <a:t>Slide 9 — Giao diện và minh chứng</a:t>
+            </a:r>
+            <a:endParaRPr lang="en-US" altLang="en-US"/>
+          </a:p>
+          <a:p>
+            <a:r>
+              <a:rPr lang="" altLang="en-US"/>
+              <a:t>Ý </a:t>
+            </a:r>
+            <a:r>
+              <a:rPr lang="en-US" altLang="en-US"/>
+              <a:t>chính trên slide: Giao diện lọc theo tháng/n</a:t>
+            </a:r>
+            <a:r>
+              <a:rPr lang="" altLang="en-US"/>
+              <a:t>ă</a:t>
+            </a:r>
+            <a:r>
+              <a:rPr lang="en-US" altLang="en-US"/>
+              <a:t>m; QA SQL xác nhận function/view, constraint và xóa kỳ; benchmark fixture riêng.</a:t>
+            </a:r>
+            <a:endParaRPr lang="en-US" altLang="en-US"/>
+          </a:p>
+          <a:p>
+            <a:endParaRPr lang="en-US" altLang="en-US"/>
+          </a:p>
+          <a:p>
+            <a:r>
+              <a:rPr lang="en-US" altLang="en-US"/>
+              <a:t>Lời nói (35 giây):</a:t>
+            </a:r>
+            <a:endParaRPr lang="en-US" altLang="en-US"/>
+          </a:p>
+          <a:p>
+            <a:endParaRPr lang="en-US" altLang="en-US"/>
+          </a:p>
+          <a:p>
+            <a:r>
+              <a:rPr lang="en-US" altLang="en-US"/>
+              <a:t>“Trên giao diện, ng</a:t>
+            </a:r>
+            <a:r>
+              <a:rPr lang="" altLang="en-US"/>
+              <a:t>ư</a:t>
+            </a:r>
+            <a:r>
+              <a:rPr lang="en-US" altLang="en-US"/>
+              <a:t>ời dùng chọn kỳ, xem hai danh sách và tổng hợp phụ cấp. HR và Payroll </a:t>
+            </a:r>
+            <a:r>
+              <a:rPr lang="" altLang="en-US"/>
+              <a:t>đư</a:t>
+            </a:r>
+            <a:r>
+              <a:rPr lang="en-US" altLang="en-US"/>
+              <a:t>ợc thao tác phụ cấp, khấu trừ theo quyền; xóa kỳ chỉ dành cho Admin hoặc Payroll. Test TV3 ngày 08/10 chạy trên database QA riêng </a:t>
+            </a:r>
+            <a:r>
+              <a:rPr lang="" altLang="en-US"/>
+              <a:t>đ</a:t>
+            </a:r>
+            <a:r>
+              <a:rPr lang="en-US" altLang="en-US"/>
+              <a:t>ã xác nhận function, view, constraint, xóa kỳ nháp, từ chối kỳ </a:t>
+            </a:r>
+            <a:r>
+              <a:rPr lang="" altLang="en-US"/>
+              <a:t>đ</a:t>
+            </a:r>
+            <a:r>
+              <a:rPr lang="en-US" altLang="en-US"/>
+              <a:t>ã chốt và cleanup fixture. Benchmark 30 nghìn dòng trên bảng tạm ghi nhận 642 logical reads tr</a:t>
+            </a:r>
+            <a:r>
+              <a:rPr lang="" altLang="en-US"/>
+              <a:t>ư</a:t>
+            </a:r>
+            <a:r>
+              <a:rPr lang="en-US" altLang="en-US"/>
+              <a:t>ớc index và 2 sau index ở lần chạy </a:t>
+            </a:r>
+            <a:r>
+              <a:rPr lang="" altLang="en-US"/>
+              <a:t>đ</a:t>
+            </a:r>
+            <a:r>
+              <a:rPr lang="en-US" altLang="en-US"/>
+              <a:t>ó; </a:t>
+            </a:r>
+            <a:r>
+              <a:rPr lang="" altLang="en-US"/>
+              <a:t>đ</a:t>
+            </a:r>
+            <a:r>
+              <a:rPr lang="en-US" altLang="en-US"/>
+              <a:t>ây là phép </a:t>
+            </a:r>
+            <a:r>
+              <a:rPr lang="" altLang="en-US"/>
+              <a:t>đ</a:t>
+            </a:r>
+            <a:r>
+              <a:rPr lang="en-US" altLang="en-US"/>
+              <a:t>o của fixture, không phải cam kết cho mọi máy. Em xin chuyển phần tính l</a:t>
+            </a:r>
+            <a:r>
+              <a:rPr lang="" altLang="en-US"/>
+              <a:t>ư</a:t>
+            </a:r>
+            <a:r>
+              <a:rPr lang="en-US" altLang="en-US"/>
+              <a:t>ơng cho TV4.”</a:t>
+            </a:r>
+            <a:endParaRPr lang="en-US" altLang="en-US"/>
           </a:p>
         </p:txBody>
       </p:sp>

</xml_diff>

<commit_message>
fix(tv3): cap nhat speaker notes slide 9, hoan thien bao cao word va dong bo provenance PR #43
</commit_message>
<xml_diff>
--- a/Bo_nop_TV3_TranTienDat/Minh_chung/TV3_Slides_7-9.pptx
+++ b/Bo_nop_TV3_TranTienDat/Minh_chung/TV3_Slides_7-9.pptx
@@ -914,7 +914,15 @@
             </a:r>
             <a:r>
               <a:rPr lang="en-US" altLang="en-US"/>
-              <a:t>ợc thao tác phụ cấp, khấu trừ theo quyền; xóa kỳ chỉ dành cho Admin hoặc Payroll. Test TV3 ngày 08/10 chạy trên database QA riêng </a:t>
+              <a:t>ợc thao tác phụ cấp, khấu trừ theo quyền; xóa kỳ chỉ dành cho Admin hoặc Payroll. Bộ kiểm thử SQL TV3 chạy ngày 13/10/2026 (l</a:t>
+            </a:r>
+            <a:r>
+              <a:rPr lang="" altLang="en-US"/>
+              <a:t>ư</a:t>
+            </a:r>
+            <a:r>
+              <a:rPr lang="en-US" altLang="en-US"/>
+              <a:t>u tại Minh_chung/Log_SQLPlan/test_module_phucap_khautru_TV3.log) </a:t>
             </a:r>
             <a:r>
               <a:rPr lang="" altLang="en-US"/>
@@ -922,7 +930,7 @@
             </a:r>
             <a:r>
               <a:rPr lang="en-US" altLang="en-US"/>
-              <a:t>ã xác nhận function, view, constraint, xóa kỳ nháp, từ chối kỳ </a:t>
+              <a:t>ã xác nhận PASS 4 cụm: function/view, chặn CHECK tiền âm và tháng sai, xóa kỳ nháp 5/2020, từ chối kỳ </a:t>
             </a:r>
             <a:r>
               <a:rPr lang="" altLang="en-US"/>
@@ -930,7 +938,7 @@
             </a:r>
             <a:r>
               <a:rPr lang="en-US" altLang="en-US"/>
-              <a:t>ã chốt và cleanup fixture. Benchmark 30 nghìn dòng trên bảng tạm ghi nhận 642 logical reads tr</a:t>
+              <a:t>ã chốt 6/2020 và cleanup fixture. Benchmark 30 nghìn dòng trên bảng tạm #PHUCAP_BENCHMARK l</a:t>
             </a:r>
             <a:r>
               <a:rPr lang="" altLang="en-US"/>
@@ -938,7 +946,15 @@
             </a:r>
             <a:r>
               <a:rPr lang="en-US" altLang="en-US"/>
-              <a:t>ớc index và 2 sau index ở lần chạy </a:t>
+              <a:t>ợt chạy ngày 13/10/2026 (l</a:t>
+            </a:r>
+            <a:r>
+              <a:rPr lang="" altLang="en-US"/>
+              <a:t>ư</a:t>
+            </a:r>
+            <a:r>
+              <a:rPr lang="en-US" altLang="en-US"/>
+              <a:t>u tại Minh_chung/Log_SQLPlan/benchmark_test_benchmark_index_TV3.log và TV3_ActualPlan.sqlplan) ghi nhận giảm từ 642 logical reads xuống còn 2 logical reads sau khi tạo index; </a:t>
             </a:r>
             <a:r>
               <a:rPr lang="" altLang="en-US"/>
@@ -946,7 +962,7 @@
             </a:r>
             <a:r>
               <a:rPr lang="en-US" altLang="en-US"/>
-              <a:t>ó; </a:t>
+              <a:t>ây là phép </a:t>
             </a:r>
             <a:r>
               <a:rPr lang="" altLang="en-US"/>
@@ -954,15 +970,15 @@
             </a:r>
             <a:r>
               <a:rPr lang="en-US" altLang="en-US"/>
-              <a:t>ây là phép </a:t>
+              <a:t>o trên fixture riêng, không phải cam kết cho mọi máy. Các ảnh tại Minh_chung/Screenshots/ chỉ dùng làm t</a:t>
             </a:r>
             <a:r>
               <a:rPr lang="" altLang="en-US"/>
-              <a:t>đ</a:t>
+              <a:t>ư </a:t>
             </a:r>
             <a:r>
               <a:rPr lang="en-US" altLang="en-US"/>
-              <a:t>o của fixture, không phải cam kết cho mọi máy. Em xin chuyển phần tính l</a:t>
+              <a:t>liệu minh họa lịch sử. Em xin chuyển phần tính l</a:t>
             </a:r>
             <a:r>
               <a:rPr lang="" altLang="en-US"/>
@@ -971,6 +987,64 @@
             <a:r>
               <a:rPr lang="en-US" altLang="en-US"/>
               <a:t>ơng cho TV4.”</a:t>
+            </a:r>
+            <a:endParaRPr lang="en-US" altLang="en-US"/>
+          </a:p>
+          <a:p>
+            <a:endParaRPr lang="en-US" altLang="en-US"/>
+          </a:p>
+          <a:p>
+            <a:r>
+              <a:rPr lang="" altLang="en-US"/>
+              <a:t>Đư</a:t>
+            </a:r>
+            <a:r>
+              <a:rPr lang="en-US" altLang="en-US"/>
+              <a:t>ờng dẫn file bằng chứng cho ng</a:t>
+            </a:r>
+            <a:r>
+              <a:rPr lang="" altLang="en-US"/>
+              <a:t>ư</a:t>
+            </a:r>
+            <a:r>
+              <a:rPr lang="en-US" altLang="en-US"/>
+              <a:t>ời ghép deck (l</a:t>
+            </a:r>
+            <a:r>
+              <a:rPr lang="" altLang="en-US"/>
+              <a:t>ư</a:t>
+            </a:r>
+            <a:r>
+              <a:rPr lang="en-US" altLang="en-US"/>
+              <a:t>ợt chạy 13/10/2026):</a:t>
+            </a:r>
+            <a:endParaRPr lang="en-US" altLang="en-US"/>
+          </a:p>
+          <a:p>
+            <a:r>
+              <a:rPr lang="en-US" altLang="en-US"/>
+              <a:t>- Log kiểm thử module (13/10/2026): Bo_nop_TV3_TranTienDat/Minh_chung/Log_SQLPlan/test_module_phucap_khautru_TV3.log</a:t>
+            </a:r>
+            <a:endParaRPr lang="en-US" altLang="en-US"/>
+          </a:p>
+          <a:p>
+            <a:r>
+              <a:rPr lang="en-US" altLang="en-US"/>
+              <a:t>- Log benchmark (13/10/2026): Bo_nop_TV3_TranTienDat/Minh_chung/Log_SQLPlan/benchmark_test_benchmark_index_TV3.log</a:t>
+            </a:r>
+            <a:endParaRPr lang="en-US" altLang="en-US"/>
+          </a:p>
+          <a:p>
+            <a:r>
+              <a:rPr lang="en-US" altLang="en-US"/>
+              <a:t>- Actual Execution Plan (13/10/2026): Bo_nop_TV3_TranTienDat/Minh_chung/Log_SQLPlan/TV3_ActualPlan.sqlplan</a:t>
+            </a:r>
+            <a:endParaRPr lang="en-US" altLang="en-US"/>
+          </a:p>
+          <a:p>
+            <a:r>
+              <a:rPr lang="en-US" altLang="en-US"/>
+              <a:t>- Ảnh minh họa lịch sử (30/09–06/10/2026): Bo_nop_TV3_TranTienDat/Minh_chung/Screenshots/</a:t>
             </a:r>
             <a:endParaRPr lang="en-US" altLang="en-US"/>
           </a:p>

</xml_diff>